<commit_message>
Add generated PDFs for lesson 1
TeX Live is now installed, so tools/build.py produces the handout PDF and a
beamer PDF of the slides alongside the .pptx. Both are committed: the
repository is the distribution channel and students should not need pandoc.

Generated in WSL, currently the only environment with a working TeX engine -
the MiKTeX install on the Windows side still refuses to run.

Also ignore .venv/, which the WSL toolchain lives in.

Co-Authored-By: Claude Opus 5 <noreply@anthropic.com>
</commit_message>
<xml_diff>
--- a/Lessons/01_introduction_and_workflow/Slides/introduction_and_workflow_slides.pptx
+++ b/Lessons/01_introduction_and_workflow/Slides/introduction_and_workflow_slides.pptx
@@ -10677,8 +10677,8 @@
         </p:blipFill>
         <p:spPr bwMode="auto">
           <a:xfrm>
-            <a:off x="457200" y="1595239"/>
-            <a:ext cx="8229600" cy="2501900"/>
+            <a:off x="457200" y="1582539"/>
+            <a:ext cx="8229600" cy="2527300"/>
           </a:xfrm>
           <a:prstGeom prst="rect">
             <a:avLst/>
@@ -11326,8 +11326,8 @@
         </p:blipFill>
         <p:spPr bwMode="auto">
           <a:xfrm>
-            <a:off x="1966916" y="1166099"/>
-            <a:ext cx="5210168" cy="3360181"/>
+            <a:off x="1973208" y="1166099"/>
+            <a:ext cx="5197583" cy="3360181"/>
           </a:xfrm>
           <a:prstGeom prst="rect">
             <a:avLst/>
@@ -11945,8 +11945,8 @@
         </p:blipFill>
         <p:spPr bwMode="auto">
           <a:xfrm>
-            <a:off x="2715720" y="1166099"/>
-            <a:ext cx="3712559" cy="3360181"/>
+            <a:off x="2722013" y="1166099"/>
+            <a:ext cx="3699974" cy="3360181"/>
           </a:xfrm>
           <a:prstGeom prst="rect">
             <a:avLst/>
@@ -12433,8 +12433,8 @@
         </p:blipFill>
         <p:spPr bwMode="auto">
           <a:xfrm>
-            <a:off x="1929161" y="1166099"/>
-            <a:ext cx="5285677" cy="3360181"/>
+            <a:off x="1916576" y="1166099"/>
+            <a:ext cx="5310847" cy="3360181"/>
           </a:xfrm>
           <a:prstGeom prst="rect">
             <a:avLst/>
@@ -12823,8 +12823,8 @@
         </p:blipFill>
         <p:spPr bwMode="auto">
           <a:xfrm>
-            <a:off x="1350253" y="1166099"/>
-            <a:ext cx="6443493" cy="3360181"/>
+            <a:off x="1343961" y="1166099"/>
+            <a:ext cx="6456078" cy="3360181"/>
           </a:xfrm>
           <a:prstGeom prst="rect">
             <a:avLst/>

</xml_diff>